<commit_message>
att monografia + profexxor x materias
</commit_message>
<xml_diff>
--- a/docs/monografia/banner_baua.pptx
+++ b/docs/monografia/banner_baua.pptx
@@ -374,7 +374,7 @@
             </a:pPr>
             <a:fld id="{C4A5D341-4EBE-4A71-8129-9C53C0EA2457}" type="datetimeFigureOut">
               <a:rPr lang="pt-BR"/>
-              <a:t>24/09/2026</a:t>
+              <a:t>25/09/2026</a:t>
             </a:fld>
             <a:endParaRPr lang="pt-BR"/>
           </a:p>
@@ -931,7 +931,7 @@
             </a:pPr>
             <a:fld id="{4FBEB365-19CE-49BC-A87B-5FAE5E1096C2}" type="datetimeFigureOut">
               <a:rPr lang="pt-BR" altLang="pt-BR"/>
-              <a:t>24/09/2026</a:t>
+              <a:t>25/09/2026</a:t>
             </a:fld>
             <a:endParaRPr lang="pt-BR" altLang="pt-BR"/>
           </a:p>
@@ -1115,7 +1115,7 @@
             </a:pPr>
             <a:fld id="{954EE6EC-1525-4423-A8D4-82B9DF5BF7ED}" type="datetimeFigureOut">
               <a:rPr lang="pt-BR" altLang="pt-BR"/>
-              <a:t>24/09/2026</a:t>
+              <a:t>25/09/2026</a:t>
             </a:fld>
             <a:endParaRPr lang="pt-BR" altLang="pt-BR"/>
           </a:p>
@@ -1309,7 +1309,7 @@
             </a:pPr>
             <a:fld id="{BA2F35B1-1408-4DD7-84DE-79FAEF80B932}" type="datetimeFigureOut">
               <a:rPr lang="pt-BR" altLang="pt-BR"/>
-              <a:t>24/09/2026</a:t>
+              <a:t>25/09/2026</a:t>
             </a:fld>
             <a:endParaRPr lang="pt-BR" altLang="pt-BR"/>
           </a:p>
@@ -1493,7 +1493,7 @@
             </a:pPr>
             <a:fld id="{D492F7D1-0405-42EE-ACB5-97F5B85A7B86}" type="datetimeFigureOut">
               <a:rPr lang="pt-BR" altLang="pt-BR"/>
-              <a:t>24/09/2026</a:t>
+              <a:t>25/09/2026</a:t>
             </a:fld>
             <a:endParaRPr lang="pt-BR" altLang="pt-BR"/>
           </a:p>
@@ -1754,7 +1754,7 @@
             </a:pPr>
             <a:fld id="{E8B227FD-2D5D-4278-8F15-0E483FE2EC43}" type="datetimeFigureOut">
               <a:rPr lang="pt-BR" altLang="pt-BR"/>
-              <a:t>24/09/2026</a:t>
+              <a:t>25/09/2026</a:t>
             </a:fld>
             <a:endParaRPr lang="pt-BR" altLang="pt-BR"/>
           </a:p>
@@ -2055,7 +2055,7 @@
             </a:pPr>
             <a:fld id="{0B52793D-877F-4D63-AA58-5607ED782E45}" type="datetimeFigureOut">
               <a:rPr lang="pt-BR" altLang="pt-BR"/>
-              <a:t>24/09/2026</a:t>
+              <a:t>25/09/2026</a:t>
             </a:fld>
             <a:endParaRPr lang="pt-BR" altLang="pt-BR"/>
           </a:p>
@@ -2495,7 +2495,7 @@
             </a:pPr>
             <a:fld id="{A74B865E-3EBC-4265-B375-EEF8F6FBC1A2}" type="datetimeFigureOut">
               <a:rPr lang="pt-BR" altLang="pt-BR"/>
-              <a:t>24/09/2026</a:t>
+              <a:t>25/09/2026</a:t>
             </a:fld>
             <a:endParaRPr lang="pt-BR" altLang="pt-BR"/>
           </a:p>
@@ -2628,7 +2628,7 @@
             </a:pPr>
             <a:fld id="{1CC77728-1E53-4CEC-98BE-EDFDF33A066A}" type="datetimeFigureOut">
               <a:rPr lang="pt-BR" altLang="pt-BR"/>
-              <a:t>24/09/2026</a:t>
+              <a:t>25/09/2026</a:t>
             </a:fld>
             <a:endParaRPr lang="pt-BR" altLang="pt-BR"/>
           </a:p>
@@ -2739,7 +2739,7 @@
             </a:pPr>
             <a:fld id="{DAAEFA4B-8D63-4C75-8413-34904A565DF0}" type="datetimeFigureOut">
               <a:rPr lang="pt-BR" altLang="pt-BR"/>
-              <a:t>24/09/2026</a:t>
+              <a:t>25/09/2026</a:t>
             </a:fld>
             <a:endParaRPr lang="pt-BR" altLang="pt-BR"/>
           </a:p>
@@ -3030,7 +3030,7 @@
             </a:pPr>
             <a:fld id="{3A3DAC36-816A-41A8-B2AA-21E73DA6278B}" type="datetimeFigureOut">
               <a:rPr lang="pt-BR" altLang="pt-BR"/>
-              <a:t>24/09/2026</a:t>
+              <a:t>25/09/2026</a:t>
             </a:fld>
             <a:endParaRPr lang="pt-BR" altLang="pt-BR"/>
           </a:p>
@@ -3301,7 +3301,7 @@
             </a:pPr>
             <a:fld id="{1ECE69EE-2AF6-4968-84E0-1B7AF7E95915}" type="datetimeFigureOut">
               <a:rPr lang="pt-BR" altLang="pt-BR"/>
-              <a:t>24/09/2026</a:t>
+              <a:t>25/09/2026</a:t>
             </a:fld>
             <a:endParaRPr lang="pt-BR" altLang="pt-BR"/>
           </a:p>
@@ -3565,7 +3565,7 @@
             </a:pPr>
             <a:fld id="{FC6A291B-ECA8-4045-8E11-DF4FD6062A15}" type="datetimeFigureOut">
               <a:rPr lang="pt-BR" altLang="pt-BR"/>
-              <a:t>24/09/2026</a:t>
+              <a:t>25/09/2026</a:t>
             </a:fld>
             <a:endParaRPr lang="pt-BR" altLang="pt-BR"/>
           </a:p>
@@ -4094,8 +4094,8 @@
         </p:nvSpPr>
         <p:spPr bwMode="auto">
           <a:xfrm>
-            <a:off x="869060" y="7858059"/>
-            <a:ext cx="15022785" cy="8865025"/>
+            <a:off x="869061" y="7858059"/>
+            <a:ext cx="14815414" cy="8865025"/>
           </a:xfrm>
           <a:prstGeom prst="rect">
             <a:avLst/>
@@ -4278,7 +4278,7 @@
         </p:nvSpPr>
         <p:spPr bwMode="auto">
           <a:xfrm>
-            <a:off x="860741" y="24330322"/>
+            <a:off x="956709" y="34539303"/>
             <a:ext cx="14567574" cy="808038"/>
           </a:xfrm>
           <a:prstGeom prst="rect">
@@ -4339,7 +4339,7 @@
         </p:nvSpPr>
         <p:spPr bwMode="auto">
           <a:xfrm>
-            <a:off x="16526580" y="24278480"/>
+            <a:off x="16479846" y="28855243"/>
             <a:ext cx="14693210" cy="808037"/>
           </a:xfrm>
           <a:prstGeom prst="rect">
@@ -4400,7 +4400,7 @@
         </p:nvSpPr>
         <p:spPr bwMode="auto">
           <a:xfrm>
-            <a:off x="16497332" y="25086517"/>
+            <a:off x="16479845" y="29736844"/>
             <a:ext cx="14693211" cy="3694379"/>
           </a:xfrm>
           <a:prstGeom prst="rect">
@@ -4568,8 +4568,8 @@
         </p:nvSpPr>
         <p:spPr bwMode="auto">
           <a:xfrm>
-            <a:off x="880944" y="17968528"/>
-            <a:ext cx="14719103" cy="7387708"/>
+            <a:off x="825609" y="18336104"/>
+            <a:ext cx="14858865" cy="7387708"/>
           </a:xfrm>
           <a:prstGeom prst="rect">
             <a:avLst/>
@@ -4606,6 +4606,22 @@
               <a:rPr lang="pt-BR" sz="3200" dirty="0"/>
               <a:t>	A segurança e a proteção de dados pessoais foram tratadas como parte da arquitetura: autenticação por JWT, senhas em hash (bcrypt), identificadores não sensíveis (GUID) em vez de CPF, e acesso escopado por escola e função, em diálogo com a LGPD (Lei nº 13.709/2018).</a:t>
             </a:r>
+          </a:p>
+          <a:p>
+            <a:pPr algn="just">
+              <a:lnSpc>
+                <a:spcPct val="150000"/>
+              </a:lnSpc>
+            </a:pPr>
+            <a:endParaRPr lang="pt-BR" sz="3200" dirty="0"/>
+          </a:p>
+          <a:p>
+            <a:pPr algn="just">
+              <a:lnSpc>
+                <a:spcPct val="150000"/>
+              </a:lnSpc>
+            </a:pPr>
+            <a:endParaRPr lang="pt-BR" sz="3200" dirty="0"/>
           </a:p>
         </p:txBody>
       </p:sp>
@@ -4699,7 +4715,7 @@
         </p:nvSpPr>
         <p:spPr bwMode="auto">
           <a:xfrm>
-            <a:off x="16500968" y="29152932"/>
+            <a:off x="16519144" y="33786554"/>
             <a:ext cx="14693210" cy="808037"/>
           </a:xfrm>
           <a:prstGeom prst="rect">
@@ -4760,8 +4776,8 @@
         </p:nvSpPr>
         <p:spPr bwMode="auto">
           <a:xfrm>
-            <a:off x="16668160" y="29998903"/>
-            <a:ext cx="14736838" cy="4433043"/>
+            <a:off x="16135603" y="34763629"/>
+            <a:ext cx="15098565" cy="6062335"/>
           </a:xfrm>
           <a:prstGeom prst="rect">
             <a:avLst/>
@@ -4778,36 +4794,578 @@
           </a:bodyPr>
           <a:lstStyle/>
           <a:p>
-            <a:pPr algn="just">
+            <a:pPr marL="302262" lvl="1" indent="0" algn="just">
               <a:lnSpc>
-                <a:spcPct val="150000"/>
+                <a:spcPts val="3920"/>
               </a:lnSpc>
             </a:pPr>
             <a:r>
-              <a:rPr lang="pt-BR" sz="4000" dirty="0"/>
-              <a:t>BRASIL. Lei nº 13.709, de 14 de agosto de 2018. Lei Geral de Proteção de Dados Pessoais (LGPD). Diário Oficial da União: seção 1, Brasília, DF, 15 ago. 2018.</a:t>
-            </a:r>
-          </a:p>
-          <a:p>
-            <a:pPr algn="just">
+              <a:rPr lang="en-US" sz="3200" dirty="0">
+                <a:solidFill>
+                  <a:srgbClr val="000000"/>
+                </a:solidFill>
+                <a:latin typeface="Arial MT Pro"/>
+                <a:ea typeface="Arial MT Pro"/>
+                <a:cs typeface="Arial MT Pro"/>
+                <a:sym typeface="Arial MT Pro"/>
+              </a:rPr>
+              <a:t>CHERNY, B. Programming TypeScript: making your JavaScript applications scale. Sebastopol: O'Reilly Media, 2019.</a:t>
+            </a:r>
+          </a:p>
+          <a:p>
+            <a:pPr marL="302262" lvl="1" indent="0" algn="just">
               <a:lnSpc>
-                <a:spcPct val="150000"/>
+                <a:spcPts val="3920"/>
               </a:lnSpc>
             </a:pPr>
             <a:r>
-              <a:rPr lang="pt-BR" sz="4000" dirty="0"/>
-              <a:t>G1. Censo Escolar registra aumento na evasão escolar do Ensino Médio. Jornal Nacional, 22 fev. 2024.</a:t>
-            </a:r>
-          </a:p>
-          <a:p>
-            <a:pPr algn="just">
+              <a:rPr lang="en-US" sz="3200" dirty="0">
+                <a:solidFill>
+                  <a:srgbClr val="000000"/>
+                </a:solidFill>
+                <a:latin typeface="Arial MT Pro"/>
+                <a:ea typeface="Arial MT Pro"/>
+                <a:cs typeface="Arial MT Pro"/>
+                <a:sym typeface="Arial MT Pro"/>
+              </a:rPr>
+              <a:t>EVOLUTION API. Evolution API. [20--]. </a:t>
+            </a:r>
+            <a:r>
+              <a:rPr lang="en-US" sz="3200" dirty="0" err="1">
+                <a:solidFill>
+                  <a:srgbClr val="000000"/>
+                </a:solidFill>
+                <a:latin typeface="Arial MT Pro"/>
+                <a:ea typeface="Arial MT Pro"/>
+                <a:cs typeface="Arial MT Pro"/>
+                <a:sym typeface="Arial MT Pro"/>
+              </a:rPr>
+              <a:t>Disponível</a:t>
+            </a:r>
+            <a:r>
+              <a:rPr lang="en-US" sz="3200" dirty="0">
+                <a:solidFill>
+                  <a:srgbClr val="000000"/>
+                </a:solidFill>
+                <a:latin typeface="Arial MT Pro"/>
+                <a:ea typeface="Arial MT Pro"/>
+                <a:cs typeface="Arial MT Pro"/>
+                <a:sym typeface="Arial MT Pro"/>
+              </a:rPr>
+              <a:t> </a:t>
+            </a:r>
+            <a:r>
+              <a:rPr lang="en-US" sz="3200" dirty="0" err="1">
+                <a:solidFill>
+                  <a:srgbClr val="000000"/>
+                </a:solidFill>
+                <a:latin typeface="Arial MT Pro"/>
+                <a:ea typeface="Arial MT Pro"/>
+                <a:cs typeface="Arial MT Pro"/>
+                <a:sym typeface="Arial MT Pro"/>
+              </a:rPr>
+              <a:t>em</a:t>
+            </a:r>
+            <a:r>
+              <a:rPr lang="en-US" sz="3200" dirty="0">
+                <a:solidFill>
+                  <a:srgbClr val="000000"/>
+                </a:solidFill>
+                <a:latin typeface="Arial MT Pro"/>
+                <a:ea typeface="Arial MT Pro"/>
+                <a:cs typeface="Arial MT Pro"/>
+                <a:sym typeface="Arial MT Pro"/>
+              </a:rPr>
+              <a:t>: https://docs.evolutionfoundation.com.br/evolution-api. </a:t>
+            </a:r>
+            <a:r>
+              <a:rPr lang="en-US" sz="3200" dirty="0" err="1">
+                <a:solidFill>
+                  <a:srgbClr val="000000"/>
+                </a:solidFill>
+                <a:latin typeface="Arial MT Pro"/>
+                <a:ea typeface="Arial MT Pro"/>
+                <a:cs typeface="Arial MT Pro"/>
+                <a:sym typeface="Arial MT Pro"/>
+              </a:rPr>
+              <a:t>Acesso</a:t>
+            </a:r>
+            <a:r>
+              <a:rPr lang="en-US" sz="3200" dirty="0">
+                <a:solidFill>
+                  <a:srgbClr val="000000"/>
+                </a:solidFill>
+                <a:latin typeface="Arial MT Pro"/>
+                <a:ea typeface="Arial MT Pro"/>
+                <a:cs typeface="Arial MT Pro"/>
+                <a:sym typeface="Arial MT Pro"/>
+              </a:rPr>
+              <a:t> </a:t>
+            </a:r>
+            <a:r>
+              <a:rPr lang="en-US" sz="3200" dirty="0" err="1">
+                <a:solidFill>
+                  <a:srgbClr val="000000"/>
+                </a:solidFill>
+                <a:latin typeface="Arial MT Pro"/>
+                <a:ea typeface="Arial MT Pro"/>
+                <a:cs typeface="Arial MT Pro"/>
+                <a:sym typeface="Arial MT Pro"/>
+              </a:rPr>
+              <a:t>em</a:t>
+            </a:r>
+            <a:r>
+              <a:rPr lang="en-US" sz="3200" dirty="0">
+                <a:solidFill>
+                  <a:srgbClr val="000000"/>
+                </a:solidFill>
+                <a:latin typeface="Arial MT Pro"/>
+                <a:ea typeface="Arial MT Pro"/>
+                <a:cs typeface="Arial MT Pro"/>
+                <a:sym typeface="Arial MT Pro"/>
+              </a:rPr>
+              <a:t>: 24 jun. 2026.</a:t>
+            </a:r>
+          </a:p>
+          <a:p>
+            <a:pPr marL="302262" lvl="1" indent="0" algn="just">
               <a:lnSpc>
-                <a:spcPct val="150000"/>
+                <a:spcPts val="3920"/>
               </a:lnSpc>
             </a:pPr>
             <a:r>
-              <a:rPr lang="pt-BR" sz="4000" dirty="0"/>
-              <a:t>MORAIS, Marcio. Diferenças entre IA Tradicional e IA Generativa (Preditiva). [20--].</a:t>
+              <a:rPr lang="en-US" sz="3200" dirty="0">
+                <a:solidFill>
+                  <a:srgbClr val="000000"/>
+                </a:solidFill>
+                <a:latin typeface="Arial MT Pro"/>
+                <a:ea typeface="Arial MT Pro"/>
+                <a:cs typeface="Arial MT Pro"/>
+                <a:sym typeface="Arial MT Pro"/>
+              </a:rPr>
+              <a:t>FETTE, I.; MELNIKOV, A. The WebSocket Protocol. RFC 6455. IETF, 2011. </a:t>
+            </a:r>
+            <a:r>
+              <a:rPr lang="en-US" sz="3200" dirty="0" err="1">
+                <a:solidFill>
+                  <a:srgbClr val="000000"/>
+                </a:solidFill>
+                <a:latin typeface="Arial MT Pro"/>
+                <a:ea typeface="Arial MT Pro"/>
+                <a:cs typeface="Arial MT Pro"/>
+                <a:sym typeface="Arial MT Pro"/>
+              </a:rPr>
+              <a:t>Disponível</a:t>
+            </a:r>
+            <a:r>
+              <a:rPr lang="en-US" sz="3200" dirty="0">
+                <a:solidFill>
+                  <a:srgbClr val="000000"/>
+                </a:solidFill>
+                <a:latin typeface="Arial MT Pro"/>
+                <a:ea typeface="Arial MT Pro"/>
+                <a:cs typeface="Arial MT Pro"/>
+                <a:sym typeface="Arial MT Pro"/>
+              </a:rPr>
+              <a:t> </a:t>
+            </a:r>
+            <a:r>
+              <a:rPr lang="en-US" sz="3200" dirty="0" err="1">
+                <a:solidFill>
+                  <a:srgbClr val="000000"/>
+                </a:solidFill>
+                <a:latin typeface="Arial MT Pro"/>
+                <a:ea typeface="Arial MT Pro"/>
+                <a:cs typeface="Arial MT Pro"/>
+                <a:sym typeface="Arial MT Pro"/>
+              </a:rPr>
+              <a:t>em</a:t>
+            </a:r>
+            <a:r>
+              <a:rPr lang="en-US" sz="3200" dirty="0">
+                <a:solidFill>
+                  <a:srgbClr val="000000"/>
+                </a:solidFill>
+                <a:latin typeface="Arial MT Pro"/>
+                <a:ea typeface="Arial MT Pro"/>
+                <a:cs typeface="Arial MT Pro"/>
+                <a:sym typeface="Arial MT Pro"/>
+              </a:rPr>
+              <a:t>: https://datatracker.ietf.org/doc/html/rfc6455. </a:t>
+            </a:r>
+            <a:r>
+              <a:rPr lang="en-US" sz="3200" dirty="0" err="1">
+                <a:solidFill>
+                  <a:srgbClr val="000000"/>
+                </a:solidFill>
+                <a:latin typeface="Arial MT Pro"/>
+                <a:ea typeface="Arial MT Pro"/>
+                <a:cs typeface="Arial MT Pro"/>
+                <a:sym typeface="Arial MT Pro"/>
+              </a:rPr>
+              <a:t>Acesso</a:t>
+            </a:r>
+            <a:r>
+              <a:rPr lang="en-US" sz="3200" dirty="0">
+                <a:solidFill>
+                  <a:srgbClr val="000000"/>
+                </a:solidFill>
+                <a:latin typeface="Arial MT Pro"/>
+                <a:ea typeface="Arial MT Pro"/>
+                <a:cs typeface="Arial MT Pro"/>
+                <a:sym typeface="Arial MT Pro"/>
+              </a:rPr>
+              <a:t> </a:t>
+            </a:r>
+            <a:r>
+              <a:rPr lang="en-US" sz="3200" dirty="0" err="1">
+                <a:solidFill>
+                  <a:srgbClr val="000000"/>
+                </a:solidFill>
+                <a:latin typeface="Arial MT Pro"/>
+                <a:ea typeface="Arial MT Pro"/>
+                <a:cs typeface="Arial MT Pro"/>
+                <a:sym typeface="Arial MT Pro"/>
+              </a:rPr>
+              <a:t>em</a:t>
+            </a:r>
+            <a:r>
+              <a:rPr lang="en-US" sz="3200" dirty="0">
+                <a:solidFill>
+                  <a:srgbClr val="000000"/>
+                </a:solidFill>
+                <a:latin typeface="Arial MT Pro"/>
+                <a:ea typeface="Arial MT Pro"/>
+                <a:cs typeface="Arial MT Pro"/>
+                <a:sym typeface="Arial MT Pro"/>
+              </a:rPr>
+              <a:t>: 24 jun. 2026.</a:t>
+            </a:r>
+          </a:p>
+          <a:p>
+            <a:pPr marL="302262" lvl="1" indent="0" algn="just">
+              <a:lnSpc>
+                <a:spcPts val="3920"/>
+              </a:lnSpc>
+            </a:pPr>
+            <a:r>
+              <a:rPr lang="en-US" sz="3200" dirty="0">
+                <a:solidFill>
+                  <a:srgbClr val="000000"/>
+                </a:solidFill>
+                <a:latin typeface="Arial MT Pro"/>
+                <a:ea typeface="Arial MT Pro"/>
+                <a:cs typeface="Arial MT Pro"/>
+                <a:sym typeface="Arial MT Pro"/>
+              </a:rPr>
+              <a:t>RAILWAY. Railway. [20--]. </a:t>
+            </a:r>
+            <a:r>
+              <a:rPr lang="en-US" sz="3200" dirty="0" err="1">
+                <a:solidFill>
+                  <a:srgbClr val="000000"/>
+                </a:solidFill>
+                <a:latin typeface="Arial MT Pro"/>
+                <a:ea typeface="Arial MT Pro"/>
+                <a:cs typeface="Arial MT Pro"/>
+                <a:sym typeface="Arial MT Pro"/>
+              </a:rPr>
+              <a:t>Disponível</a:t>
+            </a:r>
+            <a:r>
+              <a:rPr lang="en-US" sz="3200" dirty="0">
+                <a:solidFill>
+                  <a:srgbClr val="000000"/>
+                </a:solidFill>
+                <a:latin typeface="Arial MT Pro"/>
+                <a:ea typeface="Arial MT Pro"/>
+                <a:cs typeface="Arial MT Pro"/>
+                <a:sym typeface="Arial MT Pro"/>
+              </a:rPr>
+              <a:t> </a:t>
+            </a:r>
+            <a:r>
+              <a:rPr lang="en-US" sz="3200" dirty="0" err="1">
+                <a:solidFill>
+                  <a:srgbClr val="000000"/>
+                </a:solidFill>
+                <a:latin typeface="Arial MT Pro"/>
+                <a:ea typeface="Arial MT Pro"/>
+                <a:cs typeface="Arial MT Pro"/>
+                <a:sym typeface="Arial MT Pro"/>
+              </a:rPr>
+              <a:t>em</a:t>
+            </a:r>
+            <a:r>
+              <a:rPr lang="en-US" sz="3200" dirty="0">
+                <a:solidFill>
+                  <a:srgbClr val="000000"/>
+                </a:solidFill>
+                <a:latin typeface="Arial MT Pro"/>
+                <a:ea typeface="Arial MT Pro"/>
+                <a:cs typeface="Arial MT Pro"/>
+                <a:sym typeface="Arial MT Pro"/>
+              </a:rPr>
+              <a:t>: https://railway.com. </a:t>
+            </a:r>
+            <a:r>
+              <a:rPr lang="en-US" sz="3200" dirty="0" err="1">
+                <a:solidFill>
+                  <a:srgbClr val="000000"/>
+                </a:solidFill>
+                <a:latin typeface="Arial MT Pro"/>
+                <a:ea typeface="Arial MT Pro"/>
+                <a:cs typeface="Arial MT Pro"/>
+                <a:sym typeface="Arial MT Pro"/>
+              </a:rPr>
+              <a:t>Acesso</a:t>
+            </a:r>
+            <a:r>
+              <a:rPr lang="en-US" sz="3200" dirty="0">
+                <a:solidFill>
+                  <a:srgbClr val="000000"/>
+                </a:solidFill>
+                <a:latin typeface="Arial MT Pro"/>
+                <a:ea typeface="Arial MT Pro"/>
+                <a:cs typeface="Arial MT Pro"/>
+                <a:sym typeface="Arial MT Pro"/>
+              </a:rPr>
+              <a:t> </a:t>
+            </a:r>
+            <a:r>
+              <a:rPr lang="en-US" sz="3200" dirty="0" err="1">
+                <a:solidFill>
+                  <a:srgbClr val="000000"/>
+                </a:solidFill>
+                <a:latin typeface="Arial MT Pro"/>
+                <a:ea typeface="Arial MT Pro"/>
+                <a:cs typeface="Arial MT Pro"/>
+                <a:sym typeface="Arial MT Pro"/>
+              </a:rPr>
+              <a:t>em</a:t>
+            </a:r>
+            <a:r>
+              <a:rPr lang="en-US" sz="3200" dirty="0">
+                <a:solidFill>
+                  <a:srgbClr val="000000"/>
+                </a:solidFill>
+                <a:latin typeface="Arial MT Pro"/>
+                <a:ea typeface="Arial MT Pro"/>
+                <a:cs typeface="Arial MT Pro"/>
+                <a:sym typeface="Arial MT Pro"/>
+              </a:rPr>
+              <a:t>: 24 jun. 2026.</a:t>
+            </a:r>
+          </a:p>
+          <a:p>
+            <a:pPr marL="302262" lvl="1" indent="0" algn="just">
+              <a:lnSpc>
+                <a:spcPts val="3920"/>
+              </a:lnSpc>
+            </a:pPr>
+            <a:r>
+              <a:rPr lang="en-US" sz="3200" dirty="0">
+                <a:solidFill>
+                  <a:srgbClr val="000000"/>
+                </a:solidFill>
+                <a:latin typeface="Arial MT Pro"/>
+                <a:ea typeface="Arial MT Pro"/>
+                <a:cs typeface="Arial MT Pro"/>
+                <a:sym typeface="Arial MT Pro"/>
+              </a:rPr>
+              <a:t>ZARDO, H. </a:t>
+            </a:r>
+            <a:r>
+              <a:rPr lang="en-US" sz="3200" dirty="0" err="1">
+                <a:solidFill>
+                  <a:srgbClr val="000000"/>
+                </a:solidFill>
+                <a:latin typeface="Arial MT Pro"/>
+                <a:ea typeface="Arial MT Pro"/>
+                <a:cs typeface="Arial MT Pro"/>
+                <a:sym typeface="Arial MT Pro"/>
+              </a:rPr>
+              <a:t>Introdução</a:t>
+            </a:r>
+            <a:r>
+              <a:rPr lang="en-US" sz="3200" dirty="0">
+                <a:solidFill>
+                  <a:srgbClr val="000000"/>
+                </a:solidFill>
+                <a:latin typeface="Arial MT Pro"/>
+                <a:ea typeface="Arial MT Pro"/>
+                <a:cs typeface="Arial MT Pro"/>
+                <a:sym typeface="Arial MT Pro"/>
+              </a:rPr>
+              <a:t> </a:t>
+            </a:r>
+            <a:r>
+              <a:rPr lang="en-US" sz="3200" dirty="0" err="1">
+                <a:solidFill>
+                  <a:srgbClr val="000000"/>
+                </a:solidFill>
+                <a:latin typeface="Arial MT Pro"/>
+                <a:ea typeface="Arial MT Pro"/>
+                <a:cs typeface="Arial MT Pro"/>
+                <a:sym typeface="Arial MT Pro"/>
+              </a:rPr>
+              <a:t>ao</a:t>
+            </a:r>
+            <a:r>
+              <a:rPr lang="en-US" sz="3200" dirty="0">
+                <a:solidFill>
+                  <a:srgbClr val="000000"/>
+                </a:solidFill>
+                <a:latin typeface="Arial MT Pro"/>
+                <a:ea typeface="Arial MT Pro"/>
+                <a:cs typeface="Arial MT Pro"/>
+                <a:sym typeface="Arial MT Pro"/>
+              </a:rPr>
+              <a:t> </a:t>
+            </a:r>
+            <a:r>
+              <a:rPr lang="en-US" sz="3200" dirty="0" err="1">
+                <a:solidFill>
+                  <a:srgbClr val="000000"/>
+                </a:solidFill>
+                <a:latin typeface="Arial MT Pro"/>
+                <a:ea typeface="Arial MT Pro"/>
+                <a:cs typeface="Arial MT Pro"/>
+                <a:sym typeface="Arial MT Pro"/>
+              </a:rPr>
+              <a:t>padrão</a:t>
+            </a:r>
+            <a:r>
+              <a:rPr lang="en-US" sz="3200" dirty="0">
+                <a:solidFill>
+                  <a:srgbClr val="000000"/>
+                </a:solidFill>
+                <a:latin typeface="Arial MT Pro"/>
+                <a:ea typeface="Arial MT Pro"/>
+                <a:cs typeface="Arial MT Pro"/>
+                <a:sym typeface="Arial MT Pro"/>
+              </a:rPr>
+              <a:t> MVC. </a:t>
+            </a:r>
+            <a:r>
+              <a:rPr lang="en-US" sz="3200" dirty="0" err="1">
+                <a:solidFill>
+                  <a:srgbClr val="000000"/>
+                </a:solidFill>
+                <a:latin typeface="Arial MT Pro"/>
+                <a:ea typeface="Arial MT Pro"/>
+                <a:cs typeface="Arial MT Pro"/>
+                <a:sym typeface="Arial MT Pro"/>
+              </a:rPr>
+              <a:t>DevMedia</a:t>
+            </a:r>
+            <a:r>
+              <a:rPr lang="en-US" sz="3200" dirty="0">
+                <a:solidFill>
+                  <a:srgbClr val="000000"/>
+                </a:solidFill>
+                <a:latin typeface="Arial MT Pro"/>
+                <a:ea typeface="Arial MT Pro"/>
+                <a:cs typeface="Arial MT Pro"/>
+                <a:sym typeface="Arial MT Pro"/>
+              </a:rPr>
+              <a:t>, 2013. </a:t>
+            </a:r>
+            <a:r>
+              <a:rPr lang="en-US" sz="3200" dirty="0" err="1">
+                <a:solidFill>
+                  <a:srgbClr val="000000"/>
+                </a:solidFill>
+                <a:latin typeface="Arial MT Pro"/>
+                <a:ea typeface="Arial MT Pro"/>
+                <a:cs typeface="Arial MT Pro"/>
+                <a:sym typeface="Arial MT Pro"/>
+              </a:rPr>
+              <a:t>Disponível</a:t>
+            </a:r>
+            <a:r>
+              <a:rPr lang="en-US" sz="3200" dirty="0">
+                <a:solidFill>
+                  <a:srgbClr val="000000"/>
+                </a:solidFill>
+                <a:latin typeface="Arial MT Pro"/>
+                <a:ea typeface="Arial MT Pro"/>
+                <a:cs typeface="Arial MT Pro"/>
+                <a:sym typeface="Arial MT Pro"/>
+              </a:rPr>
+              <a:t> </a:t>
+            </a:r>
+            <a:r>
+              <a:rPr lang="en-US" sz="3200" dirty="0" err="1">
+                <a:solidFill>
+                  <a:srgbClr val="000000"/>
+                </a:solidFill>
+                <a:latin typeface="Arial MT Pro"/>
+                <a:ea typeface="Arial MT Pro"/>
+                <a:cs typeface="Arial MT Pro"/>
+                <a:sym typeface="Arial MT Pro"/>
+              </a:rPr>
+              <a:t>em</a:t>
+            </a:r>
+            <a:r>
+              <a:rPr lang="en-US" sz="3200" dirty="0">
+                <a:solidFill>
+                  <a:srgbClr val="000000"/>
+                </a:solidFill>
+                <a:latin typeface="Arial MT Pro"/>
+                <a:ea typeface="Arial MT Pro"/>
+                <a:cs typeface="Arial MT Pro"/>
+                <a:sym typeface="Arial MT Pro"/>
+              </a:rPr>
+              <a:t>: https://www.devmedia.com.br/introducao-ao-padrao-mvc/29308. </a:t>
+            </a:r>
+            <a:r>
+              <a:rPr lang="en-US" sz="3200" dirty="0" err="1">
+                <a:solidFill>
+                  <a:srgbClr val="000000"/>
+                </a:solidFill>
+                <a:latin typeface="Arial MT Pro"/>
+                <a:ea typeface="Arial MT Pro"/>
+                <a:cs typeface="Arial MT Pro"/>
+                <a:sym typeface="Arial MT Pro"/>
+              </a:rPr>
+              <a:t>Acesso</a:t>
+            </a:r>
+            <a:r>
+              <a:rPr lang="en-US" sz="3200" dirty="0">
+                <a:solidFill>
+                  <a:srgbClr val="000000"/>
+                </a:solidFill>
+                <a:latin typeface="Arial MT Pro"/>
+                <a:ea typeface="Arial MT Pro"/>
+                <a:cs typeface="Arial MT Pro"/>
+                <a:sym typeface="Arial MT Pro"/>
+              </a:rPr>
+              <a:t> </a:t>
+            </a:r>
+            <a:r>
+              <a:rPr lang="en-US" sz="3200" dirty="0" err="1">
+                <a:solidFill>
+                  <a:srgbClr val="000000"/>
+                </a:solidFill>
+                <a:latin typeface="Arial MT Pro"/>
+                <a:ea typeface="Arial MT Pro"/>
+                <a:cs typeface="Arial MT Pro"/>
+                <a:sym typeface="Arial MT Pro"/>
+              </a:rPr>
+              <a:t>em</a:t>
+            </a:r>
+            <a:r>
+              <a:rPr lang="en-US" sz="3200" dirty="0">
+                <a:solidFill>
+                  <a:srgbClr val="000000"/>
+                </a:solidFill>
+                <a:latin typeface="Arial MT Pro"/>
+                <a:ea typeface="Arial MT Pro"/>
+                <a:cs typeface="Arial MT Pro"/>
+                <a:sym typeface="Arial MT Pro"/>
+              </a:rPr>
+              <a:t>: 10 abr. 2026.</a:t>
             </a:r>
           </a:p>
         </p:txBody>
@@ -4822,8 +5380,8 @@
         </p:nvSpPr>
         <p:spPr bwMode="auto">
           <a:xfrm>
-            <a:off x="890878" y="25217250"/>
-            <a:ext cx="14693211" cy="7971383"/>
+            <a:off x="825609" y="35634652"/>
+            <a:ext cx="14858865" cy="6895255"/>
           </a:xfrm>
           <a:prstGeom prst="rect">
             <a:avLst/>
@@ -4842,13 +5400,442 @@
           <a:p>
             <a:pPr algn="just">
               <a:lnSpc>
+                <a:spcPct val="100000"/>
+              </a:lnSpc>
+            </a:pPr>
+            <a:r>
+              <a:rPr lang="pt-BR" sz="3200" dirty="0"/>
+              <a:t>	</a:t>
+            </a:r>
+            <a:r>
+              <a:rPr lang="en-US" sz="4000" dirty="0"/>
+              <a:t>O </a:t>
+            </a:r>
+            <a:r>
+              <a:rPr lang="en-US" sz="4000" dirty="0" err="1"/>
+              <a:t>desenvolvimento</a:t>
+            </a:r>
+            <a:r>
+              <a:rPr lang="en-US" sz="4000" dirty="0"/>
+              <a:t> do </a:t>
+            </a:r>
+            <a:r>
+              <a:rPr lang="en-US" sz="4000" dirty="0" err="1"/>
+              <a:t>Ecossistema</a:t>
+            </a:r>
+            <a:r>
+              <a:rPr lang="en-US" sz="4000" dirty="0"/>
+              <a:t> Escolar </a:t>
+            </a:r>
+            <a:r>
+              <a:rPr lang="en-US" sz="4000" dirty="0" err="1"/>
+              <a:t>permitiu</a:t>
+            </a:r>
+            <a:r>
+              <a:rPr lang="en-US" sz="4000" dirty="0"/>
+              <a:t> </a:t>
+            </a:r>
+            <a:r>
+              <a:rPr lang="en-US" sz="4000" dirty="0" err="1"/>
+              <a:t>alcançar</a:t>
+            </a:r>
+            <a:r>
+              <a:rPr lang="en-US" sz="4000" dirty="0"/>
+              <a:t> </a:t>
+            </a:r>
+            <a:r>
+              <a:rPr lang="en-US" sz="4000" dirty="0" err="1"/>
+              <a:t>os</a:t>
+            </a:r>
+            <a:r>
+              <a:rPr lang="en-US" sz="4000" dirty="0"/>
+              <a:t> </a:t>
+            </a:r>
+            <a:r>
+              <a:rPr lang="en-US" sz="4000" dirty="0" err="1"/>
+              <a:t>objetivos</a:t>
+            </a:r>
+            <a:r>
+              <a:rPr lang="en-US" sz="4000" dirty="0"/>
+              <a:t> </a:t>
+            </a:r>
+            <a:r>
+              <a:rPr lang="en-US" sz="4000" dirty="0" err="1"/>
+              <a:t>inicialmente</a:t>
+            </a:r>
+            <a:r>
+              <a:rPr lang="en-US" sz="4000" dirty="0"/>
+              <a:t> </a:t>
+            </a:r>
+            <a:r>
+              <a:rPr lang="en-US" sz="4000" dirty="0" err="1"/>
+              <a:t>propostos</a:t>
+            </a:r>
+            <a:r>
+              <a:rPr lang="en-US" sz="4000" dirty="0"/>
+              <a:t>, </a:t>
+            </a:r>
+            <a:r>
+              <a:rPr lang="en-US" sz="4000" dirty="0" err="1"/>
+              <a:t>sendo</a:t>
+            </a:r>
+            <a:r>
+              <a:rPr lang="en-US" sz="4000" dirty="0"/>
+              <a:t>, </a:t>
+            </a:r>
+            <a:r>
+              <a:rPr lang="en-US" sz="4000" dirty="0" err="1"/>
+              <a:t>em</a:t>
+            </a:r>
+            <a:r>
+              <a:rPr lang="en-US" sz="4000" dirty="0"/>
+              <a:t> </a:t>
+            </a:r>
+            <a:r>
+              <a:rPr lang="en-US" sz="4000" dirty="0" err="1"/>
+              <a:t>diversos</a:t>
+            </a:r>
+            <a:r>
+              <a:rPr lang="en-US" sz="4000" dirty="0"/>
+              <a:t> aspectos, </a:t>
+            </a:r>
+            <a:r>
+              <a:rPr lang="en-US" sz="4000" dirty="0" err="1"/>
+              <a:t>ampliado</a:t>
+            </a:r>
+            <a:r>
+              <a:rPr lang="en-US" sz="4000" dirty="0"/>
+              <a:t> </a:t>
+            </a:r>
+            <a:r>
+              <a:rPr lang="en-US" sz="4000" dirty="0" err="1"/>
+              <a:t>ao</a:t>
+            </a:r>
+            <a:r>
+              <a:rPr lang="en-US" sz="4000" dirty="0"/>
+              <a:t> </a:t>
+            </a:r>
+            <a:r>
+              <a:rPr lang="en-US" sz="4000" dirty="0" err="1"/>
+              <a:t>longo</a:t>
+            </a:r>
+            <a:r>
+              <a:rPr lang="en-US" sz="4000" dirty="0"/>
+              <a:t> da </a:t>
+            </a:r>
+            <a:r>
+              <a:rPr lang="en-US" sz="4000" dirty="0" err="1"/>
+              <a:t>execução</a:t>
+            </a:r>
+            <a:r>
+              <a:rPr lang="en-US" sz="4000" dirty="0"/>
+              <a:t> do </a:t>
+            </a:r>
+            <a:r>
+              <a:rPr lang="en-US" sz="4000" dirty="0" err="1"/>
+              <a:t>projeto</a:t>
+            </a:r>
+            <a:r>
+              <a:rPr lang="en-US" sz="4000" dirty="0"/>
+              <a:t>. A </a:t>
+            </a:r>
+            <a:r>
+              <a:rPr lang="en-US" sz="4000" dirty="0" err="1"/>
+              <a:t>proposta</a:t>
+            </a:r>
+            <a:r>
+              <a:rPr lang="en-US" sz="4000" dirty="0"/>
+              <a:t> </a:t>
+            </a:r>
+            <a:r>
+              <a:rPr lang="en-US" sz="4000" dirty="0" err="1"/>
+              <a:t>inicial</a:t>
+            </a:r>
+            <a:r>
+              <a:rPr lang="en-US" sz="4000" dirty="0"/>
+              <a:t> </a:t>
+            </a:r>
+            <a:r>
+              <a:rPr lang="en-US" sz="4000" dirty="0" err="1"/>
+              <a:t>estava</a:t>
+            </a:r>
+            <a:r>
+              <a:rPr lang="en-US" sz="4000" dirty="0"/>
+              <a:t> </a:t>
+            </a:r>
+            <a:r>
+              <a:rPr lang="en-US" sz="4000" dirty="0" err="1"/>
+              <a:t>voltada</a:t>
+            </a:r>
+            <a:r>
+              <a:rPr lang="en-US" sz="4000" dirty="0"/>
+              <a:t> </a:t>
+            </a:r>
+            <a:r>
+              <a:rPr lang="en-US" sz="4000" dirty="0" err="1"/>
+              <a:t>principalmente</a:t>
+            </a:r>
+            <a:r>
+              <a:rPr lang="en-US" sz="4000" dirty="0"/>
+              <a:t> </a:t>
+            </a:r>
+            <a:r>
+              <a:rPr lang="en-US" sz="4000" dirty="0" err="1"/>
+              <a:t>ao</a:t>
+            </a:r>
+            <a:r>
+              <a:rPr lang="en-US" sz="4000" dirty="0"/>
+              <a:t> </a:t>
+            </a:r>
+            <a:r>
+              <a:rPr lang="en-US" sz="4000" dirty="0" err="1"/>
+              <a:t>controle</a:t>
+            </a:r>
+            <a:r>
+              <a:rPr lang="en-US" sz="4000" dirty="0"/>
+              <a:t> de </a:t>
+            </a:r>
+            <a:r>
+              <a:rPr lang="en-US" sz="4000" dirty="0" err="1"/>
+              <a:t>avisos</a:t>
+            </a:r>
+            <a:r>
+              <a:rPr lang="en-US" sz="4000" dirty="0"/>
+              <a:t> </a:t>
+            </a:r>
+            <a:r>
+              <a:rPr lang="en-US" sz="4000" dirty="0" err="1"/>
+              <a:t>institucionais</a:t>
+            </a:r>
+            <a:r>
+              <a:rPr lang="en-US" sz="4000" dirty="0"/>
+              <a:t> e </a:t>
+            </a:r>
+            <a:r>
+              <a:rPr lang="en-US" sz="4000" dirty="0" err="1"/>
+              <a:t>ao</a:t>
+            </a:r>
+            <a:r>
+              <a:rPr lang="en-US" sz="4000" dirty="0"/>
+              <a:t> </a:t>
+            </a:r>
+            <a:r>
+              <a:rPr lang="en-US" sz="4000" dirty="0" err="1"/>
+              <a:t>acompanhamento</a:t>
+            </a:r>
+            <a:r>
+              <a:rPr lang="en-US" sz="4000" dirty="0"/>
+              <a:t> de </a:t>
+            </a:r>
+            <a:r>
+              <a:rPr lang="en-US" sz="4000" dirty="0" err="1"/>
+              <a:t>atividades</a:t>
+            </a:r>
+            <a:r>
+              <a:rPr lang="en-US" sz="4000" dirty="0"/>
+              <a:t> </a:t>
+            </a:r>
+            <a:r>
+              <a:rPr lang="en-US" sz="4000" dirty="0" err="1"/>
+              <a:t>acadêmicas</a:t>
+            </a:r>
+            <a:r>
+              <a:rPr lang="en-US" sz="4000" dirty="0"/>
+              <a:t>; </a:t>
+            </a:r>
+            <a:r>
+              <a:rPr lang="en-US" sz="4000" dirty="0" err="1"/>
+              <a:t>contudo</a:t>
+            </a:r>
+            <a:r>
+              <a:rPr lang="en-US" sz="4000" dirty="0"/>
+              <a:t>, </a:t>
+            </a:r>
+            <a:r>
+              <a:rPr lang="en-US" sz="4000" dirty="0" err="1"/>
+              <a:t>durante</a:t>
+            </a:r>
+            <a:r>
+              <a:rPr lang="en-US" sz="4000" dirty="0"/>
+              <a:t> a </a:t>
+            </a:r>
+            <a:r>
+              <a:rPr lang="en-US" sz="4000" dirty="0" err="1"/>
+              <a:t>análise</a:t>
+            </a:r>
+            <a:r>
+              <a:rPr lang="en-US" sz="4000" dirty="0"/>
+              <a:t>, a </a:t>
+            </a:r>
+            <a:r>
+              <a:rPr lang="en-US" sz="4000" dirty="0" err="1"/>
+              <a:t>modelagem</a:t>
+            </a:r>
+            <a:r>
+              <a:rPr lang="en-US" sz="4000" dirty="0"/>
+              <a:t> e a </a:t>
+            </a:r>
+            <a:r>
+              <a:rPr lang="en-US" sz="4000" dirty="0" err="1"/>
+              <a:t>implementação</a:t>
+            </a:r>
+            <a:r>
+              <a:rPr lang="en-US" sz="4000" dirty="0"/>
+              <a:t>, o </a:t>
+            </a:r>
+            <a:r>
+              <a:rPr lang="en-US" sz="4000" dirty="0" err="1"/>
+              <a:t>escopo</a:t>
+            </a:r>
+            <a:r>
+              <a:rPr lang="en-US" sz="4000" dirty="0"/>
+              <a:t> </a:t>
+            </a:r>
+            <a:r>
+              <a:rPr lang="en-US" sz="4000" dirty="0" err="1"/>
+              <a:t>foi</a:t>
+            </a:r>
+            <a:r>
+              <a:rPr lang="en-US" sz="4000" dirty="0"/>
+              <a:t> </a:t>
+            </a:r>
+            <a:r>
+              <a:rPr lang="en-US" sz="4000" dirty="0" err="1"/>
+              <a:t>expandido</a:t>
+            </a:r>
+            <a:r>
+              <a:rPr lang="en-US" sz="4000" dirty="0"/>
+              <a:t> para </a:t>
+            </a:r>
+            <a:r>
+              <a:rPr lang="en-US" sz="4000" dirty="0" err="1"/>
+              <a:t>incorporar</a:t>
+            </a:r>
+            <a:r>
+              <a:rPr lang="en-US" sz="4000" dirty="0"/>
+              <a:t> </a:t>
+            </a:r>
+            <a:r>
+              <a:rPr lang="en-US" sz="4000" dirty="0" err="1"/>
+              <a:t>organização</a:t>
+            </a:r>
+            <a:r>
+              <a:rPr lang="en-US" sz="4000" dirty="0"/>
+              <a:t> </a:t>
+            </a:r>
+            <a:r>
+              <a:rPr lang="en-US" sz="4000" dirty="0" err="1"/>
+              <a:t>acadêmica</a:t>
+            </a:r>
+            <a:r>
+              <a:rPr lang="en-US" sz="4000" dirty="0"/>
+              <a:t>, </a:t>
+            </a:r>
+            <a:r>
+              <a:rPr lang="en-US" sz="4000" dirty="0" err="1"/>
+              <a:t>comunicação</a:t>
+            </a:r>
+            <a:r>
+              <a:rPr lang="en-US" sz="4000" dirty="0"/>
+              <a:t> entre </a:t>
+            </a:r>
+            <a:r>
+              <a:rPr lang="en-US" sz="4000" dirty="0" err="1"/>
+              <a:t>usuários</a:t>
+            </a:r>
+            <a:r>
+              <a:rPr lang="en-US" sz="4000" dirty="0"/>
+              <a:t>, </a:t>
+            </a:r>
+            <a:r>
+              <a:rPr lang="en-US" sz="4000" dirty="0" err="1"/>
+              <a:t>gerenciamento</a:t>
+            </a:r>
+            <a:r>
+              <a:rPr lang="en-US" sz="4000" dirty="0"/>
+              <a:t> de </a:t>
+            </a:r>
+            <a:r>
+              <a:rPr lang="en-US" sz="4000" dirty="0" err="1"/>
+              <a:t>grupos</a:t>
+            </a:r>
+            <a:r>
+              <a:rPr lang="en-US" sz="4000" dirty="0"/>
+              <a:t>, </a:t>
+            </a:r>
+            <a:r>
+              <a:rPr lang="en-US" sz="4000" dirty="0" err="1"/>
+              <a:t>notificações</a:t>
+            </a:r>
+            <a:r>
+              <a:rPr lang="en-US" sz="4000" dirty="0"/>
+              <a:t> </a:t>
+            </a:r>
+            <a:r>
+              <a:rPr lang="en-US" sz="4000" dirty="0" err="1"/>
+              <a:t>automatizadas</a:t>
+            </a:r>
+            <a:r>
+              <a:rPr lang="en-US" sz="4000" dirty="0"/>
+              <a:t> e </a:t>
+            </a:r>
+            <a:r>
+              <a:rPr lang="en-US" sz="4000" dirty="0" err="1"/>
+              <a:t>mecanismos</a:t>
+            </a:r>
+            <a:r>
+              <a:rPr lang="en-US" sz="4000" dirty="0"/>
+              <a:t> de </a:t>
+            </a:r>
+            <a:r>
+              <a:rPr lang="en-US" sz="4000" dirty="0" err="1"/>
+              <a:t>apoio</a:t>
+            </a:r>
+            <a:r>
+              <a:rPr lang="en-US" sz="4000" dirty="0"/>
+              <a:t> </a:t>
+            </a:r>
+            <a:r>
+              <a:rPr lang="en-US" sz="4000" dirty="0" err="1"/>
+              <a:t>aos</a:t>
+            </a:r>
+            <a:r>
+              <a:rPr lang="en-US" sz="4000" dirty="0"/>
+              <a:t> </a:t>
+            </a:r>
+            <a:r>
+              <a:rPr lang="en-US" sz="4000" dirty="0" err="1"/>
+              <a:t>estudos</a:t>
+            </a:r>
+            <a:r>
+              <a:rPr lang="en-US" sz="4000" dirty="0"/>
+              <a:t> </a:t>
+            </a:r>
+            <a:r>
+              <a:rPr lang="en-US" sz="4000" dirty="0" err="1"/>
+              <a:t>por</a:t>
+            </a:r>
+            <a:r>
+              <a:rPr lang="en-US" sz="4000" dirty="0"/>
+              <a:t> </a:t>
+            </a:r>
+            <a:r>
+              <a:rPr lang="en-US" sz="4000" dirty="0" err="1"/>
+              <a:t>inteligência</a:t>
+            </a:r>
+            <a:r>
+              <a:rPr lang="en-US" sz="4000" dirty="0"/>
+              <a:t> artificial.</a:t>
+            </a:r>
+            <a:endParaRPr lang="pt-BR" sz="4000" dirty="0"/>
+          </a:p>
+          <a:p>
+            <a:pPr algn="just">
+              <a:lnSpc>
                 <a:spcPct val="150000"/>
               </a:lnSpc>
             </a:pPr>
-            <a:r>
-              <a:rPr lang="pt-BR" sz="3200" dirty="0"/>
-              <a:t>	O desenvolvimento resultou em um sistema funcional que centraliza calendário acadêmico, tarefas, provas, comunicação entre usuários e recomendações de estudo geradas por inteligência artificial (Google Gemini), a partir de conteúdo real cadastrado pelos professores. A validação foi conduzida por meio de testes funcionais manuais e testes de endpoints via Postman, cobrindo os principais fluxos de uso de cada perfil (aluno, professor, coordenação, direção e secretaria).</a:t>
-            </a:r>
+            <a:endParaRPr lang="pt-BR" sz="3200" dirty="0"/>
           </a:p>
         </p:txBody>
       </p:sp>
@@ -5086,7 +6073,7 @@
         </p:nvSpPr>
         <p:spPr bwMode="auto">
           <a:xfrm>
-            <a:off x="16503003" y="17150252"/>
+            <a:off x="16517495" y="21849832"/>
             <a:ext cx="14405977" cy="808037"/>
           </a:xfrm>
           <a:prstGeom prst="rect">
@@ -5226,7 +6213,7 @@
           <a:bodyPr/>
           <a:lstStyle/>
           <a:p>
-            <a:endParaRPr lang="pt-BR"/>
+            <a:endParaRPr lang="pt-BR" dirty="0"/>
           </a:p>
         </p:txBody>
       </p:sp>
@@ -5238,7 +6225,7 @@
         </p:nvSpPr>
         <p:spPr>
           <a:xfrm>
-            <a:off x="16497332" y="18094886"/>
+            <a:off x="16515508" y="22655854"/>
             <a:ext cx="14709169" cy="5910401"/>
           </a:xfrm>
           <a:prstGeom prst="rect">
@@ -5277,142 +6264,13 @@
       </p:sp>
       <p:sp>
         <p:nvSpPr>
-          <p:cNvPr id="50" name="Rectangle 9"/>
-          <p:cNvSpPr>
-            <a:spLocks noChangeArrowheads="1"/>
-          </p:cNvSpPr>
-          <p:nvPr/>
-        </p:nvSpPr>
-        <p:spPr bwMode="auto">
-          <a:xfrm>
-            <a:off x="706634" y="40265714"/>
-            <a:ext cx="14893413" cy="523220"/>
-          </a:xfrm>
-          <a:prstGeom prst="rect">
-            <a:avLst/>
-          </a:prstGeom>
-          <a:noFill/>
-          <a:ln>
-            <a:noFill/>
-          </a:ln>
-          <a:effectLst/>
-          <a:extLst>
-            <a:ext uri="{909E8E84-426E-40DD-AFC4-6F175D3DCCD1}">
-              <a14:hiddenFill xmlns:a14="http://schemas.microsoft.com/office/drawing/2010/main">
-                <a:solidFill>
-                  <a:schemeClr val="accent1"/>
-                </a:solidFill>
-              </a14:hiddenFill>
-            </a:ext>
-            <a:ext uri="{91240B29-F687-4F45-9708-019B960494DF}">
-              <a14:hiddenLine xmlns:a14="http://schemas.microsoft.com/office/drawing/2010/main" w="9525">
-                <a:solidFill>
-                  <a:schemeClr val="tx1"/>
-                </a:solidFill>
-                <a:miter lim="800000"/>
-                <a:headEnd/>
-                <a:tailEnd/>
-              </a14:hiddenLine>
-            </a:ext>
-            <a:ext uri="{AF507438-7753-43E0-B8FC-AC1667EBCBE1}">
-              <a14:hiddenEffects xmlns:a14="http://schemas.microsoft.com/office/drawing/2010/main">
-                <a:effectLst>
-                  <a:outerShdw dist="35921" dir="2700000" algn="ctr" rotWithShape="0">
-                    <a:schemeClr val="bg2"/>
-                  </a:outerShdw>
-                </a:effectLst>
-              </a14:hiddenEffects>
-            </a:ext>
-          </a:extLst>
-        </p:spPr>
-        <p:txBody>
-          <a:bodyPr vert="horz" wrap="square" lIns="91440" tIns="45720" rIns="91440" bIns="45720" numCol="1" anchor="ctr" anchorCtr="0" compatLnSpc="1">
-            <a:spAutoFit/>
-          </a:bodyPr>
-          <a:lstStyle/>
-          <a:p>
-            <a:pPr marL="0" marR="0" lvl="0" indent="180975" algn="ctr" defTabSz="914400" rtl="0" eaLnBrk="0" fontAlgn="base" latinLnBrk="0" hangingPunct="0">
-              <a:lnSpc>
-                <a:spcPct val="100000"/>
-              </a:lnSpc>
-              <a:spcBef>
-                <a:spcPct val="0"/>
-              </a:spcBef>
-              <a:spcAft>
-                <a:spcPct val="0"/>
-              </a:spcAft>
-              <a:buClrTx/>
-              <a:buSzTx/>
-              <a:buFontTx/>
-              <a:buNone/>
-            </a:pPr>
-            <a:r>
-              <a:rPr kumimoji="0" lang="pt-BR" altLang="pt-BR" sz="2800" b="0" i="0" u="none" strike="noStrike" cap="none" normalizeH="0" baseline="0" dirty="0">
-                <a:ln>
-                  <a:noFill/>
-                </a:ln>
-                <a:solidFill>
-                  <a:schemeClr val="tx1"/>
-                </a:solidFill>
-                <a:effectLst/>
-                <a:latin typeface="Arial" panose="020B0604020202020204" pitchFamily="34" charset="0"/>
-                <a:ea typeface="Times New Roman" panose="02020603050405020304" pitchFamily="18" charset="0"/>
-                <a:cs typeface="Arial" panose="020B0604020202020204" pitchFamily="34" charset="0"/>
-              </a:rPr>
-              <a:t>Fonte: Autores (2026).</a:t>
-            </a:r>
-            <a:endParaRPr kumimoji="0" lang="pt-BR" altLang="pt-BR" sz="2800" b="0" i="0" u="none" strike="noStrike" cap="none" normalizeH="0" baseline="0" dirty="0">
-              <a:ln>
-                <a:noFill/>
-              </a:ln>
-              <a:solidFill>
-                <a:schemeClr val="tx1"/>
-              </a:solidFill>
-              <a:effectLst/>
-              <a:latin typeface="Arial" panose="020B0604020202020204" pitchFamily="34" charset="0"/>
-            </a:endParaRPr>
-          </a:p>
-        </p:txBody>
-      </p:sp>
-      <p:sp>
-        <p:nvSpPr>
-          <p:cNvPr id="10" name="CaixaDeTexto 15"/>
-          <p:cNvSpPr txBox="1"/>
-          <p:nvPr/>
-        </p:nvSpPr>
-        <p:spPr>
-          <a:xfrm>
-            <a:off x="860742" y="30946665"/>
-            <a:ext cx="14739306" cy="507831"/>
-          </a:xfrm>
-          <a:prstGeom prst="rect">
-            <a:avLst/>
-          </a:prstGeom>
-          <a:noFill/>
-        </p:spPr>
-        <p:txBody>
-          <a:bodyPr wrap="square" rtlCol="0">
-            <a:spAutoFit/>
-          </a:bodyPr>
-          <a:lstStyle/>
-          <a:p>
-            <a:pPr algn="ctr"/>
-            <a:r>
-              <a:rPr lang="pt-BR" sz="2700" dirty="0"/>
-              <a:t>Figura 1- Arquitetura dos agentes de inteligência artificial.</a:t>
-            </a:r>
-          </a:p>
-        </p:txBody>
-      </p:sp>
-      <p:sp>
-        <p:nvSpPr>
           <p:cNvPr id="8" name="Caixa de Texto 7"/>
           <p:cNvSpPr txBox="1"/>
           <p:nvPr/>
         </p:nvSpPr>
         <p:spPr>
           <a:xfrm>
-            <a:off x="19010337" y="7483030"/>
+            <a:off x="2580800" y="24513787"/>
             <a:ext cx="10657184" cy="923330"/>
           </a:xfrm>
           <a:prstGeom prst="rect">
@@ -5452,7 +6310,7 @@
                 <a:latin typeface="Arial" panose="020B0604020202020204"/>
                 <a:ea typeface="Times New Roman" panose="02020603050405020304"/>
               </a:rPr>
-              <a:t>2</a:t>
+              <a:t>1</a:t>
             </a:r>
             <a:r>
               <a:rPr sz="2700" dirty="0">
@@ -5572,7 +6430,7 @@
         </p:nvSpPr>
         <p:spPr bwMode="auto">
           <a:xfrm>
-            <a:off x="15068299" y="16608065"/>
+            <a:off x="-1306150" y="33684582"/>
             <a:ext cx="17460263" cy="523220"/>
           </a:xfrm>
           <a:prstGeom prst="rect">
@@ -5677,8 +6535,8 @@
         </p:blipFill>
         <p:spPr>
           <a:xfrm>
-            <a:off x="16512207" y="8663169"/>
-            <a:ext cx="14572449" cy="7953665"/>
+            <a:off x="623168" y="25652094"/>
+            <a:ext cx="14861298" cy="8111319"/>
           </a:xfrm>
           <a:prstGeom prst="rect">
             <a:avLst/>
@@ -5687,28 +6545,710 @@
       </p:pic>
       <p:pic>
         <p:nvPicPr>
-          <p:cNvPr id="2190" name="Picture 2189" descr="banner_fig_agentesIA.png"/>
+          <p:cNvPr id="11" name="Picture 3">
+            <a:extLst>
+              <a:ext uri="{FF2B5EF4-FFF2-40B4-BE49-F238E27FC236}">
+                <a16:creationId xmlns:a16="http://schemas.microsoft.com/office/drawing/2014/main" id="{7C30209F-DE3A-7301-DA2B-0DD0BCBF02C6}"/>
+              </a:ext>
+            </a:extLst>
+          </p:cNvPr>
           <p:cNvPicPr>
             <a:picLocks noChangeAspect="1"/>
           </p:cNvPicPr>
           <p:nvPr/>
         </p:nvPicPr>
-        <p:blipFill>
+        <p:blipFill rotWithShape="1">
           <a:blip r:embed="rId7"/>
+          <a:srcRect l="15189" r="15484"/>
           <a:stretch>
             <a:fillRect/>
           </a:stretch>
         </p:blipFill>
+        <p:spPr bwMode="auto">
+          <a:xfrm>
+            <a:off x="16275721" y="12974884"/>
+            <a:ext cx="14962454" cy="7679220"/>
+          </a:xfrm>
+          <a:prstGeom prst="rect">
+            <a:avLst/>
+          </a:prstGeom>
+          <a:ln>
+            <a:noFill/>
+          </a:ln>
+          <a:extLst>
+            <a:ext uri="{53640926-AAD7-44D8-BBD7-CCE9431645EC}">
+              <a14:shadowObscured xmlns:a14="http://schemas.microsoft.com/office/drawing/2010/main"/>
+            </a:ext>
+          </a:extLst>
+        </p:spPr>
+      </p:pic>
+      <p:sp>
+        <p:nvSpPr>
+          <p:cNvPr id="14" name="Rectangle 9">
+            <a:extLst>
+              <a:ext uri="{FF2B5EF4-FFF2-40B4-BE49-F238E27FC236}">
+                <a16:creationId xmlns:a16="http://schemas.microsoft.com/office/drawing/2014/main" id="{F3DFEA89-3C42-5FC2-39DA-38A77169017E}"/>
+              </a:ext>
+            </a:extLst>
+          </p:cNvPr>
+          <p:cNvSpPr>
+            <a:spLocks noChangeArrowheads="1"/>
+          </p:cNvSpPr>
+          <p:nvPr/>
+        </p:nvSpPr>
+        <p:spPr bwMode="auto">
+          <a:xfrm>
+            <a:off x="16446005" y="20780399"/>
+            <a:ext cx="14722458" cy="523220"/>
+          </a:xfrm>
+          <a:prstGeom prst="rect">
+            <a:avLst/>
+          </a:prstGeom>
+          <a:noFill/>
+          <a:ln>
+            <a:noFill/>
+          </a:ln>
+          <a:effectLst/>
+          <a:extLst>
+            <a:ext uri="{909E8E84-426E-40DD-AFC4-6F175D3DCCD1}">
+              <a14:hiddenFill xmlns:a14="http://schemas.microsoft.com/office/drawing/2010/main">
+                <a:solidFill>
+                  <a:schemeClr val="accent1"/>
+                </a:solidFill>
+              </a14:hiddenFill>
+            </a:ext>
+            <a:ext uri="{91240B29-F687-4F45-9708-019B960494DF}">
+              <a14:hiddenLine xmlns:a14="http://schemas.microsoft.com/office/drawing/2010/main" w="9525">
+                <a:solidFill>
+                  <a:schemeClr val="tx1"/>
+                </a:solidFill>
+                <a:miter lim="800000"/>
+                <a:headEnd/>
+                <a:tailEnd/>
+              </a14:hiddenLine>
+            </a:ext>
+            <a:ext uri="{AF507438-7753-43E0-B8FC-AC1667EBCBE1}">
+              <a14:hiddenEffects xmlns:a14="http://schemas.microsoft.com/office/drawing/2010/main">
+                <a:effectLst>
+                  <a:outerShdw dist="35921" dir="2700000" algn="ctr" rotWithShape="0">
+                    <a:schemeClr val="bg2"/>
+                  </a:outerShdw>
+                </a:effectLst>
+              </a14:hiddenEffects>
+            </a:ext>
+          </a:extLst>
+        </p:spPr>
+        <p:txBody>
+          <a:bodyPr vert="horz" wrap="square" lIns="91440" tIns="45720" rIns="91440" bIns="45720" numCol="1" anchor="ctr" anchorCtr="0" compatLnSpc="1">
+            <a:spAutoFit/>
+          </a:bodyPr>
+          <a:lstStyle/>
+          <a:p>
+            <a:pPr marL="0" marR="0" lvl="0" indent="180975" algn="ctr" defTabSz="914400" rtl="0" eaLnBrk="0" fontAlgn="base" latinLnBrk="0" hangingPunct="0">
+              <a:lnSpc>
+                <a:spcPct val="100000"/>
+              </a:lnSpc>
+              <a:spcBef>
+                <a:spcPct val="0"/>
+              </a:spcBef>
+              <a:spcAft>
+                <a:spcPct val="0"/>
+              </a:spcAft>
+              <a:buClrTx/>
+              <a:buSzTx/>
+              <a:buFontTx/>
+              <a:buNone/>
+            </a:pPr>
+            <a:r>
+              <a:rPr kumimoji="0" lang="pt-BR" altLang="pt-BR" sz="2800" b="0" i="0" u="none" strike="noStrike" cap="none" normalizeH="0" baseline="0" dirty="0">
+                <a:ln>
+                  <a:noFill/>
+                </a:ln>
+                <a:solidFill>
+                  <a:schemeClr val="tx1"/>
+                </a:solidFill>
+                <a:effectLst/>
+                <a:latin typeface="Arial" panose="020B0604020202020204" pitchFamily="34" charset="0"/>
+                <a:ea typeface="Times New Roman" panose="02020603050405020304" pitchFamily="18" charset="0"/>
+                <a:cs typeface="Arial" panose="020B0604020202020204" pitchFamily="34" charset="0"/>
+              </a:rPr>
+              <a:t>Fonte: Autores (2026).</a:t>
+            </a:r>
+            <a:endParaRPr kumimoji="0" lang="pt-BR" altLang="pt-BR" sz="2800" b="0" i="0" u="none" strike="noStrike" cap="none" normalizeH="0" baseline="0" dirty="0">
+              <a:ln>
+                <a:noFill/>
+              </a:ln>
+              <a:solidFill>
+                <a:schemeClr val="tx1"/>
+              </a:solidFill>
+              <a:effectLst/>
+              <a:latin typeface="Arial" panose="020B0604020202020204" pitchFamily="34" charset="0"/>
+            </a:endParaRPr>
+          </a:p>
+        </p:txBody>
+      </p:sp>
+      <p:sp>
+        <p:nvSpPr>
+          <p:cNvPr id="22" name="Caixa de Texto 7">
+            <a:extLst>
+              <a:ext uri="{FF2B5EF4-FFF2-40B4-BE49-F238E27FC236}">
+                <a16:creationId xmlns:a16="http://schemas.microsoft.com/office/drawing/2014/main" id="{B708A9F2-BE9B-B11F-D038-078FDF766E67}"/>
+              </a:ext>
+            </a:extLst>
+          </p:cNvPr>
+          <p:cNvSpPr txBox="1"/>
+          <p:nvPr/>
+        </p:nvSpPr>
         <p:spPr>
           <a:xfrm>
-            <a:off x="1194266" y="32019994"/>
-            <a:ext cx="14750779" cy="8232778"/>
+            <a:off x="18478642" y="12366937"/>
+            <a:ext cx="10657184" cy="507831"/>
           </a:xfrm>
           <a:prstGeom prst="rect">
             <a:avLst/>
           </a:prstGeom>
         </p:spPr>
-      </p:pic>
+        <p:txBody>
+          <a:bodyPr wrap="square">
+            <a:spAutoFit/>
+          </a:bodyPr>
+          <a:lstStyle/>
+          <a:p>
+            <a:pPr algn="ctr" defTabSz="266700"/>
+            <a:r>
+              <a:rPr sz="2700" dirty="0" err="1">
+                <a:latin typeface="Arial" panose="020B0604020202020204"/>
+                <a:ea typeface="Times New Roman" panose="02020603050405020304"/>
+              </a:rPr>
+              <a:t>Figura</a:t>
+            </a:r>
+            <a:r>
+              <a:rPr sz="2700" dirty="0">
+                <a:latin typeface="Arial" panose="020B0604020202020204"/>
+                <a:ea typeface="Times New Roman" panose="02020603050405020304"/>
+              </a:rPr>
+              <a:t> </a:t>
+            </a:r>
+            <a:r>
+              <a:rPr lang="pt-BR" sz="2700" dirty="0">
+                <a:latin typeface="Arial" panose="020B0604020202020204"/>
+                <a:ea typeface="Times New Roman" panose="02020603050405020304"/>
+              </a:rPr>
+              <a:t>2 - </a:t>
+            </a:r>
+            <a:r>
+              <a:rPr lang="en-US" sz="2700" dirty="0" err="1"/>
+              <a:t>Painel</a:t>
+            </a:r>
+            <a:r>
+              <a:rPr lang="en-US" sz="2700" dirty="0"/>
+              <a:t> </a:t>
+            </a:r>
+            <a:r>
+              <a:rPr lang="en-US" sz="2700" dirty="0" err="1"/>
+              <a:t>inicial</a:t>
+            </a:r>
+            <a:r>
+              <a:rPr lang="en-US" sz="2700" dirty="0"/>
+              <a:t> (dashboard) da </a:t>
+            </a:r>
+            <a:r>
+              <a:rPr lang="en-US" sz="2700" dirty="0" err="1"/>
+              <a:t>plataforma</a:t>
+            </a:r>
+            <a:endParaRPr sz="2700" dirty="0">
+              <a:latin typeface="Arial" panose="020B0604020202020204"/>
+              <a:ea typeface="Times New Roman" panose="02020603050405020304"/>
+            </a:endParaRPr>
+          </a:p>
+        </p:txBody>
+      </p:sp>
+      <p:sp>
+        <p:nvSpPr>
+          <p:cNvPr id="26" name="CaixaDeTexto 26">
+            <a:extLst>
+              <a:ext uri="{FF2B5EF4-FFF2-40B4-BE49-F238E27FC236}">
+                <a16:creationId xmlns:a16="http://schemas.microsoft.com/office/drawing/2014/main" id="{5E70CAB6-AD04-5E7C-C830-1D7C19675311}"/>
+              </a:ext>
+            </a:extLst>
+          </p:cNvPr>
+          <p:cNvSpPr txBox="1">
+            <a:spLocks noChangeArrowheads="1"/>
+          </p:cNvSpPr>
+          <p:nvPr/>
+        </p:nvSpPr>
+        <p:spPr bwMode="auto">
+          <a:xfrm>
+            <a:off x="16491961" y="7135223"/>
+            <a:ext cx="14719103" cy="5664159"/>
+          </a:xfrm>
+          <a:prstGeom prst="rect">
+            <a:avLst/>
+          </a:prstGeom>
+          <a:noFill/>
+          <a:ln w="9525">
+            <a:noFill/>
+            <a:miter lim="800000"/>
+          </a:ln>
+        </p:spPr>
+        <p:txBody>
+          <a:bodyPr wrap="square" lIns="91424" tIns="45710" rIns="91424" bIns="45710">
+            <a:spAutoFit/>
+          </a:bodyPr>
+          <a:lstStyle/>
+          <a:p>
+            <a:pPr algn="just">
+              <a:lnSpc>
+                <a:spcPct val="100000"/>
+              </a:lnSpc>
+            </a:pPr>
+            <a:r>
+              <a:rPr lang="pt-BR" sz="3200" dirty="0"/>
+              <a:t>	</a:t>
+            </a:r>
+            <a:r>
+              <a:rPr lang="en-US" sz="3200" dirty="0"/>
+              <a:t>Para </a:t>
+            </a:r>
+            <a:r>
+              <a:rPr lang="en-US" sz="3200" dirty="0" err="1"/>
+              <a:t>avaliar</a:t>
+            </a:r>
+            <a:r>
+              <a:rPr lang="en-US" sz="3200" dirty="0"/>
+              <a:t> o </a:t>
+            </a:r>
+            <a:r>
+              <a:rPr lang="en-US" sz="3200" dirty="0" err="1"/>
+              <a:t>desempenho</a:t>
+            </a:r>
+            <a:r>
+              <a:rPr lang="en-US" sz="3200" dirty="0"/>
+              <a:t> </a:t>
+            </a:r>
+            <a:r>
+              <a:rPr lang="en-US" sz="3200" dirty="0" err="1"/>
+              <a:t>prático</a:t>
+            </a:r>
+            <a:r>
+              <a:rPr lang="en-US" sz="3200" dirty="0"/>
+              <a:t> e a </a:t>
+            </a:r>
+            <a:r>
+              <a:rPr lang="en-US" sz="3200" dirty="0" err="1"/>
+              <a:t>aceitação</a:t>
+            </a:r>
+            <a:r>
+              <a:rPr lang="en-US" sz="3200" dirty="0"/>
+              <a:t> da ferramenta, </a:t>
+            </a:r>
+            <a:r>
+              <a:rPr lang="en-US" sz="3200" dirty="0" err="1"/>
+              <a:t>além</a:t>
+            </a:r>
+            <a:r>
+              <a:rPr lang="en-US" sz="3200" dirty="0"/>
+              <a:t> da </a:t>
+            </a:r>
+            <a:r>
+              <a:rPr lang="en-US" sz="3200" dirty="0" err="1"/>
+              <a:t>validação</a:t>
+            </a:r>
+            <a:r>
+              <a:rPr lang="en-US" sz="3200" dirty="0"/>
+              <a:t> </a:t>
+            </a:r>
+            <a:r>
+              <a:rPr lang="en-US" sz="3200" dirty="0" err="1"/>
+              <a:t>técnica</a:t>
+            </a:r>
+            <a:r>
+              <a:rPr lang="en-US" sz="3200" dirty="0"/>
+              <a:t> de </a:t>
+            </a:r>
+            <a:r>
+              <a:rPr lang="en-US" sz="3200" dirty="0" err="1"/>
+              <a:t>fluxos</a:t>
+            </a:r>
+            <a:r>
+              <a:rPr lang="en-US" sz="3200" dirty="0"/>
+              <a:t> via testes </a:t>
+            </a:r>
+            <a:r>
+              <a:rPr lang="en-US" sz="3200" dirty="0" err="1"/>
+              <a:t>manuais</a:t>
+            </a:r>
+            <a:r>
+              <a:rPr lang="en-US" sz="3200" dirty="0"/>
+              <a:t> e endpoints no Postman, a </a:t>
+            </a:r>
+            <a:r>
+              <a:rPr lang="en-US" sz="3200" dirty="0" err="1"/>
+              <a:t>plataforma</a:t>
+            </a:r>
+            <a:r>
+              <a:rPr lang="en-US" sz="3200" dirty="0"/>
+              <a:t> </a:t>
+            </a:r>
+            <a:r>
+              <a:rPr lang="en-US" sz="3200" dirty="0" err="1"/>
+              <a:t>passou</a:t>
+            </a:r>
+            <a:r>
+              <a:rPr lang="en-US" sz="3200" dirty="0"/>
+              <a:t> </a:t>
+            </a:r>
+            <a:r>
+              <a:rPr lang="en-US" sz="3200" dirty="0" err="1"/>
+              <a:t>por</a:t>
+            </a:r>
+            <a:r>
+              <a:rPr lang="en-US" sz="3200" dirty="0"/>
+              <a:t> um teste </a:t>
+            </a:r>
+            <a:r>
+              <a:rPr lang="en-US" sz="3200" dirty="0" err="1"/>
+              <a:t>piloto</a:t>
+            </a:r>
+            <a:r>
+              <a:rPr lang="en-US" sz="3200" dirty="0"/>
+              <a:t> de </a:t>
+            </a:r>
+            <a:r>
+              <a:rPr lang="en-US" sz="3200" dirty="0" err="1"/>
+              <a:t>usabilidade</a:t>
+            </a:r>
+            <a:r>
+              <a:rPr lang="en-US" sz="3200" dirty="0"/>
+              <a:t> </a:t>
+            </a:r>
+            <a:r>
+              <a:rPr lang="en-US" sz="3200" dirty="0" err="1"/>
+              <a:t>em</a:t>
+            </a:r>
+            <a:r>
+              <a:rPr lang="en-US" sz="3200" dirty="0"/>
+              <a:t> </a:t>
+            </a:r>
+            <a:r>
+              <a:rPr lang="en-US" sz="3200" dirty="0" err="1"/>
+              <a:t>ambiente</a:t>
+            </a:r>
+            <a:r>
+              <a:rPr lang="en-US" sz="3200" dirty="0"/>
+              <a:t> </a:t>
+            </a:r>
+            <a:r>
+              <a:rPr lang="en-US" sz="3200" dirty="0" err="1"/>
+              <a:t>controlado</a:t>
+            </a:r>
+            <a:r>
+              <a:rPr lang="en-US" sz="3200" dirty="0"/>
+              <a:t>. A </a:t>
+            </a:r>
+            <a:r>
+              <a:rPr lang="en-US" sz="3200" dirty="0" err="1"/>
+              <a:t>amostra</a:t>
+            </a:r>
+            <a:r>
+              <a:rPr lang="en-US" sz="3200" dirty="0"/>
+              <a:t> </a:t>
+            </a:r>
+            <a:r>
+              <a:rPr lang="en-US" sz="3200" dirty="0" err="1"/>
+              <a:t>contou</a:t>
+            </a:r>
+            <a:r>
+              <a:rPr lang="en-US" sz="3200" dirty="0"/>
+              <a:t> com a </a:t>
+            </a:r>
+            <a:r>
+              <a:rPr lang="en-US" sz="3200" dirty="0" err="1"/>
+              <a:t>participação</a:t>
+            </a:r>
+            <a:r>
+              <a:rPr lang="en-US" sz="3200" dirty="0"/>
+              <a:t> de 10 </a:t>
+            </a:r>
+            <a:r>
+              <a:rPr lang="en-US" sz="3200" dirty="0" err="1"/>
+              <a:t>alunos</a:t>
+            </a:r>
+            <a:r>
+              <a:rPr lang="en-US" sz="3200" dirty="0"/>
+              <a:t>, </a:t>
+            </a:r>
+            <a:r>
+              <a:rPr lang="en-US" sz="3200" dirty="0" err="1"/>
+              <a:t>utilizando</a:t>
+            </a:r>
+            <a:r>
+              <a:rPr lang="en-US" sz="3200" dirty="0"/>
+              <a:t> dados reais </a:t>
+            </a:r>
+            <a:r>
+              <a:rPr lang="en-US" sz="3200" dirty="0" err="1"/>
+              <a:t>controlados</a:t>
+            </a:r>
+            <a:r>
+              <a:rPr lang="en-US" sz="3200" dirty="0"/>
+              <a:t> e </a:t>
+            </a:r>
+            <a:r>
+              <a:rPr lang="en-US" sz="3200" dirty="0" err="1"/>
+              <a:t>não</a:t>
+            </a:r>
+            <a:r>
+              <a:rPr lang="en-US" sz="3200" dirty="0"/>
+              <a:t> </a:t>
+            </a:r>
+            <a:r>
+              <a:rPr lang="en-US" sz="3200" dirty="0" err="1"/>
+              <a:t>sensíveis</a:t>
+            </a:r>
+            <a:r>
+              <a:rPr lang="en-US" sz="3200" dirty="0"/>
+              <a:t> dos </a:t>
+            </a:r>
+            <a:r>
+              <a:rPr lang="en-US" sz="3200" dirty="0" err="1"/>
+              <a:t>próprios</a:t>
+            </a:r>
+            <a:r>
+              <a:rPr lang="en-US" sz="3200" dirty="0"/>
+              <a:t> </a:t>
+            </a:r>
+            <a:r>
+              <a:rPr lang="en-US" sz="3200" dirty="0" err="1"/>
+              <a:t>voluntários</a:t>
+            </a:r>
+            <a:r>
+              <a:rPr lang="en-US" sz="3200" dirty="0"/>
+              <a:t> (</a:t>
+            </a:r>
+            <a:r>
+              <a:rPr lang="en-US" sz="3200" dirty="0" err="1"/>
+              <a:t>como</a:t>
+            </a:r>
+            <a:r>
+              <a:rPr lang="en-US" sz="3200" dirty="0"/>
+              <a:t> e-mail e </a:t>
+            </a:r>
+            <a:r>
+              <a:rPr lang="en-US" sz="3200" dirty="0" err="1"/>
+              <a:t>número</a:t>
+            </a:r>
+            <a:r>
+              <a:rPr lang="en-US" sz="3200" dirty="0"/>
+              <a:t> de </a:t>
+            </a:r>
+            <a:r>
+              <a:rPr lang="en-US" sz="3200" dirty="0" err="1"/>
+              <a:t>telefone</a:t>
+            </a:r>
+            <a:r>
+              <a:rPr lang="en-US" sz="3200" dirty="0"/>
+              <a:t> para o </a:t>
+            </a:r>
+            <a:r>
+              <a:rPr lang="en-US" sz="3200" dirty="0" err="1"/>
+              <a:t>recebimento</a:t>
+            </a:r>
+            <a:r>
+              <a:rPr lang="en-US" sz="3200" dirty="0"/>
+              <a:t> </a:t>
+            </a:r>
+            <a:r>
+              <a:rPr lang="en-US" sz="3200" dirty="0" err="1"/>
+              <a:t>efetivo</a:t>
+            </a:r>
+            <a:r>
+              <a:rPr lang="en-US" sz="3200" dirty="0"/>
+              <a:t> das </a:t>
+            </a:r>
+            <a:r>
+              <a:rPr lang="en-US" sz="3200" dirty="0" err="1"/>
+              <a:t>notificações</a:t>
+            </a:r>
+            <a:r>
+              <a:rPr lang="en-US" sz="3200" dirty="0"/>
+              <a:t> via WhatsApp e Evolution API). </a:t>
+            </a:r>
+          </a:p>
+          <a:p>
+            <a:pPr algn="just">
+              <a:lnSpc>
+                <a:spcPct val="100000"/>
+              </a:lnSpc>
+            </a:pPr>
+            <a:r>
+              <a:rPr lang="en-US" sz="3200" dirty="0"/>
+              <a:t>	A </a:t>
+            </a:r>
+            <a:r>
+              <a:rPr lang="en-US" sz="3200" dirty="0" err="1"/>
+              <a:t>avaliação</a:t>
+            </a:r>
+            <a:r>
+              <a:rPr lang="en-US" sz="3200" dirty="0"/>
+              <a:t> </a:t>
+            </a:r>
+            <a:r>
+              <a:rPr lang="en-US" sz="3200" dirty="0" err="1"/>
+              <a:t>qualitativa</a:t>
+            </a:r>
+            <a:r>
+              <a:rPr lang="en-US" sz="3200" dirty="0"/>
+              <a:t> </a:t>
+            </a:r>
+            <a:r>
+              <a:rPr lang="en-US" sz="3200" dirty="0" err="1"/>
+              <a:t>indicou</a:t>
+            </a:r>
+            <a:r>
+              <a:rPr lang="en-US" sz="3200" dirty="0"/>
+              <a:t> </a:t>
+            </a:r>
+            <a:r>
+              <a:rPr lang="en-US" sz="3200" dirty="0" err="1"/>
+              <a:t>elevada</a:t>
+            </a:r>
+            <a:r>
+              <a:rPr lang="en-US" sz="3200" dirty="0"/>
+              <a:t> </a:t>
+            </a:r>
+            <a:r>
+              <a:rPr lang="en-US" sz="3200" dirty="0" err="1"/>
+              <a:t>aceitação</a:t>
+            </a:r>
+            <a:r>
+              <a:rPr lang="en-US" sz="3200" dirty="0"/>
+              <a:t>, com </a:t>
+            </a:r>
+            <a:r>
+              <a:rPr lang="en-US" sz="3200" dirty="0" err="1"/>
+              <a:t>retornos</a:t>
+            </a:r>
+            <a:r>
+              <a:rPr lang="en-US" sz="3200" dirty="0"/>
+              <a:t> </a:t>
+            </a:r>
+            <a:r>
+              <a:rPr lang="en-US" sz="3200" dirty="0" err="1"/>
+              <a:t>positivos</a:t>
+            </a:r>
+            <a:r>
+              <a:rPr lang="en-US" sz="3200" dirty="0"/>
+              <a:t> </a:t>
+            </a:r>
+            <a:r>
+              <a:rPr lang="en-US" sz="3200" dirty="0" err="1"/>
+              <a:t>voltados</a:t>
+            </a:r>
+            <a:r>
+              <a:rPr lang="en-US" sz="3200" dirty="0"/>
+              <a:t> à </a:t>
+            </a:r>
+            <a:r>
+              <a:rPr lang="en-US" sz="3200" dirty="0" err="1"/>
+              <a:t>fluidez</a:t>
+            </a:r>
+            <a:r>
+              <a:rPr lang="en-US" sz="3200" dirty="0"/>
+              <a:t> da interface, à </a:t>
+            </a:r>
+            <a:r>
+              <a:rPr lang="en-US" sz="3200" dirty="0" err="1"/>
+              <a:t>comodidade</a:t>
+            </a:r>
+            <a:r>
+              <a:rPr lang="en-US" sz="3200" dirty="0"/>
+              <a:t> de ter </a:t>
+            </a:r>
+            <a:r>
+              <a:rPr lang="en-US" sz="3200" dirty="0" err="1"/>
+              <a:t>os</a:t>
+            </a:r>
+            <a:r>
+              <a:rPr lang="en-US" sz="3200" dirty="0"/>
+              <a:t> </a:t>
+            </a:r>
+            <a:r>
+              <a:rPr lang="en-US" sz="3200" dirty="0" err="1"/>
+              <a:t>compromissos</a:t>
+            </a:r>
+            <a:r>
+              <a:rPr lang="en-US" sz="3200" dirty="0"/>
+              <a:t> </a:t>
+            </a:r>
+            <a:r>
+              <a:rPr lang="en-US" sz="3200" dirty="0" err="1"/>
+              <a:t>escolares</a:t>
+            </a:r>
+            <a:r>
+              <a:rPr lang="en-US" sz="3200" dirty="0"/>
+              <a:t> </a:t>
+            </a:r>
+            <a:r>
+              <a:rPr lang="en-US" sz="3200" dirty="0" err="1"/>
+              <a:t>centralizados</a:t>
+            </a:r>
+            <a:r>
+              <a:rPr lang="en-US" sz="3200" dirty="0"/>
+              <a:t> e à </a:t>
+            </a:r>
+            <a:r>
+              <a:rPr lang="en-US" sz="3200" dirty="0" err="1"/>
+              <a:t>pertinência</a:t>
+            </a:r>
+            <a:r>
+              <a:rPr lang="en-US" sz="3200" dirty="0"/>
+              <a:t> dos </a:t>
+            </a:r>
+            <a:r>
+              <a:rPr lang="en-US" sz="3200" dirty="0" err="1"/>
+              <a:t>materiais</a:t>
+            </a:r>
+            <a:r>
+              <a:rPr lang="en-US" sz="3200" dirty="0"/>
+              <a:t> </a:t>
+            </a:r>
+            <a:r>
+              <a:rPr lang="en-US" sz="3200" dirty="0" err="1"/>
+              <a:t>sugeridos</a:t>
+            </a:r>
+            <a:r>
+              <a:rPr lang="en-US" sz="3200" dirty="0"/>
+              <a:t> </a:t>
+            </a:r>
+            <a:r>
+              <a:rPr lang="en-US" sz="3200" dirty="0" err="1"/>
+              <a:t>pelo</a:t>
+            </a:r>
+            <a:r>
+              <a:rPr lang="en-US" sz="3200" dirty="0"/>
+              <a:t> </a:t>
+            </a:r>
+            <a:r>
+              <a:rPr lang="en-US" sz="3200" dirty="0" err="1"/>
+              <a:t>assistente</a:t>
+            </a:r>
+            <a:r>
+              <a:rPr lang="en-US" sz="3200" dirty="0"/>
+              <a:t> virtual.</a:t>
+            </a:r>
+            <a:endParaRPr lang="pt-BR" sz="3200" dirty="0"/>
+          </a:p>
+          <a:p>
+            <a:pPr algn="just">
+              <a:lnSpc>
+                <a:spcPct val="150000"/>
+              </a:lnSpc>
+            </a:pPr>
+            <a:endParaRPr lang="pt-BR" sz="3200" dirty="0"/>
+          </a:p>
+        </p:txBody>
+      </p:sp>
     </p:spTree>
   </p:cSld>
   <p:clrMapOvr>

</xml_diff>